<commit_message>
Point links to the renamed repo, Strat-IQ-Strategy-Toolkit
Co-Authored-By: Claude Opus 5.5 <noreply@anthropic.com>
Claude-Session: https://claude.ai/code/session_01X5wRPLvDNAfKFFNbzhL7V8
</commit_message>
<xml_diff>
--- a/release-assets/StratIQ_v3_Parts2-3_Walkthrough.pptx
+++ b/release-assets/StratIQ_v3_Parts2-3_Walkthrough.pptx
@@ -18503,7 +18503,7 @@
                 <a:ea typeface="Arial" pitchFamily="34" charset="-122"/>
                 <a:cs typeface="Arial" pitchFamily="34" charset="-120"/>
               </a:rPr>
-              <a:t>github.com/Brads777/stratos-external-analysis → Releases → latest → Assets → stratiq-part2-3-skills.zip. Unzip it once: 29 skill zips inside. Don't unzip those.</a:t>
+              <a:t>github.com/Brads777/Strat-IQ-Strategy-Toolkit → Releases → latest → Assets → stratiq-part2-3-skills.zip. Unzip it once: 29 skill zips inside. Don't unzip those.</a:t>
             </a:r>
             <a:endParaRPr lang="en-US" sz="1600" dirty="0"/>
           </a:p>
@@ -19787,7 +19787,7 @@
                 <a:ea typeface="Arial" pitchFamily="34" charset="-122"/>
                 <a:cs typeface="Arial" pitchFamily="34" charset="-120"/>
               </a:rPr>
-              <a:t>cp -r …/part2/skills/stratiq-* …/part3/skills/stratiq-* ~/.claude/skills/   ·   Full guide: brads777.github.io/stratos-external-analysis/part2-3-guide.html</a:t>
+              <a:t>cp -r …/part2/skills/stratiq-* …/part3/skills/stratiq-* ~/.claude/skills/   ·   Full guide: brads777.github.io/Strat-IQ-Strategy-Toolkit/part2-3-guide.html</a:t>
             </a:r>
             <a:endParaRPr lang="en-US" sz="1200" dirty="0"/>
           </a:p>

</xml_diff>